<commit_message>
docs: Unify API response JSON blocks and update docs PPTX
Made-with: Cursor
</commit_message>
<xml_diff>
--- a/documents/04_20260325_발표자료.pptx
+++ b/documents/04_20260325_발표자료.pptx
@@ -5,7 +5,7 @@
     <p:sldMasterId id="2147483659" r:id="rId1"/>
   </p:sldMasterIdLst>
   <p:notesMasterIdLst>
-    <p:notesMasterId r:id="rId16"/>
+    <p:notesMasterId r:id="rId17"/>
   </p:notesMasterIdLst>
   <p:sldIdLst>
     <p:sldId id="256" r:id="rId2"/>
@@ -19,9 +19,10 @@
     <p:sldId id="284" r:id="rId10"/>
     <p:sldId id="285" r:id="rId11"/>
     <p:sldId id="286" r:id="rId12"/>
-    <p:sldId id="275" r:id="rId13"/>
-    <p:sldId id="276" r:id="rId14"/>
-    <p:sldId id="277" r:id="rId15"/>
+    <p:sldId id="287" r:id="rId13"/>
+    <p:sldId id="275" r:id="rId14"/>
+    <p:sldId id="276" r:id="rId15"/>
+    <p:sldId id="277" r:id="rId16"/>
   </p:sldIdLst>
   <p:sldSz cx="9144000" cy="5143500" type="screen16x9"/>
   <p:notesSz cx="6858000" cy="9144000"/>
@@ -6689,6 +6690,99 @@
   <p:cSld>
     <p:spTree>
       <p:nvGrpSpPr>
+        <p:cNvPr id="1" name=""/>
+        <p:cNvGrpSpPr/>
+        <p:nvPr/>
+      </p:nvGrpSpPr>
+      <p:grpSpPr>
+        <a:xfrm>
+          <a:off x="0" y="0"/>
+          <a:ext cx="0" cy="0"/>
+          <a:chOff x="0" y="0"/>
+          <a:chExt cx="0" cy="0"/>
+        </a:xfrm>
+      </p:grpSpPr>
+      <p:sp>
+        <p:nvSpPr>
+          <p:cNvPr id="2" name="제목 1">
+            <a:extLst>
+              <a:ext uri="{FF2B5EF4-FFF2-40B4-BE49-F238E27FC236}">
+                <a16:creationId xmlns:a16="http://schemas.microsoft.com/office/drawing/2014/main" id="{3D419BDB-478B-78E2-6374-95CAC1066A43}"/>
+              </a:ext>
+            </a:extLst>
+          </p:cNvPr>
+          <p:cNvSpPr>
+            <a:spLocks noGrp="1"/>
+          </p:cNvSpPr>
+          <p:nvPr>
+            <p:ph type="title"/>
+          </p:nvPr>
+        </p:nvSpPr>
+        <p:spPr/>
+        <p:txBody>
+          <a:bodyPr>
+            <a:normAutofit fontScale="90000"/>
+          </a:bodyPr>
+          <a:lstStyle/>
+          <a:p>
+            <a:r>
+              <a:rPr lang="en-US" altLang="ko-KR" dirty="0"/>
+              <a:t>API </a:t>
+            </a:r>
+            <a:r>
+              <a:rPr lang="ko-KR" altLang="en-US" dirty="0"/>
+              <a:t>설계</a:t>
+            </a:r>
+          </a:p>
+        </p:txBody>
+      </p:sp>
+      <p:sp>
+        <p:nvSpPr>
+          <p:cNvPr id="3" name="텍스트 개체 틀 2">
+            <a:extLst>
+              <a:ext uri="{FF2B5EF4-FFF2-40B4-BE49-F238E27FC236}">
+                <a16:creationId xmlns:a16="http://schemas.microsoft.com/office/drawing/2014/main" id="{C0519DAF-7F49-8505-65AB-248A55A39A8F}"/>
+              </a:ext>
+            </a:extLst>
+          </p:cNvPr>
+          <p:cNvSpPr>
+            <a:spLocks noGrp="1"/>
+          </p:cNvSpPr>
+          <p:nvPr>
+            <p:ph type="body" idx="1"/>
+          </p:nvPr>
+        </p:nvSpPr>
+        <p:spPr/>
+        <p:txBody>
+          <a:bodyPr/>
+          <a:lstStyle/>
+          <a:p>
+            <a:r>
+              <a:rPr lang="en-US" altLang="ko-KR" dirty="0"/>
+              <a:t>https://documentaidocs-production.up.railway.app/</a:t>
+            </a:r>
+            <a:endParaRPr lang="ko-KR" altLang="en-US" dirty="0"/>
+          </a:p>
+        </p:txBody>
+      </p:sp>
+    </p:spTree>
+    <p:extLst>
+      <p:ext uri="{BB962C8B-B14F-4D97-AF65-F5344CB8AC3E}">
+        <p14:creationId xmlns:p14="http://schemas.microsoft.com/office/powerpoint/2010/main" val="3947091310"/>
+      </p:ext>
+    </p:extLst>
+  </p:cSld>
+  <p:clrMapOvr>
+    <a:masterClrMapping/>
+  </p:clrMapOvr>
+</p:sld>
+</file>
+
+<file path=ppt/slides/slide13.xml><?xml version="1.0" encoding="utf-8"?>
+<p:sld xmlns:a="http://schemas.openxmlformats.org/drawingml/2006/main" xmlns:r="http://schemas.openxmlformats.org/officeDocument/2006/relationships" xmlns:p="http://schemas.openxmlformats.org/presentationml/2006/main">
+  <p:cSld>
+    <p:spTree>
+      <p:nvGrpSpPr>
         <p:cNvPr id="1" name="Shape 168"/>
         <p:cNvGrpSpPr/>
         <p:nvPr/>
@@ -6824,10 +6918,9 @@
               <a:t>개발계</a:t>
             </a:r>
             <a:r>
-              <a:rPr lang="en-US" altLang="ko-KR"/>
+              <a:rPr lang="en-US" altLang="ko-KR" dirty="0"/>
               <a:t>)</a:t>
             </a:r>
-            <a:endParaRPr lang="en-US" altLang="ko-KR" dirty="0"/>
           </a:p>
           <a:p>
             <a:pPr marL="914400" lvl="1" indent="-317500" algn="l" rtl="0">
@@ -6904,7 +6997,7 @@
 </p:sld>
 </file>
 
-<file path=ppt/slides/slide13.xml><?xml version="1.0" encoding="utf-8"?>
+<file path=ppt/slides/slide14.xml><?xml version="1.0" encoding="utf-8"?>
 <p:sld xmlns:a="http://schemas.openxmlformats.org/drawingml/2006/main" xmlns:r="http://schemas.openxmlformats.org/officeDocument/2006/relationships" xmlns:p="http://schemas.openxmlformats.org/presentationml/2006/main">
   <p:cSld>
     <p:spTree>
@@ -7010,7 +7103,7 @@
 </p:sld>
 </file>
 
-<file path=ppt/slides/slide14.xml><?xml version="1.0" encoding="utf-8"?>
+<file path=ppt/slides/slide15.xml><?xml version="1.0" encoding="utf-8"?>
 <p:sld xmlns:a="http://schemas.openxmlformats.org/drawingml/2006/main" xmlns:r="http://schemas.openxmlformats.org/officeDocument/2006/relationships" xmlns:p="http://schemas.openxmlformats.org/presentationml/2006/main">
   <p:cSld>
     <p:spTree>

</xml_diff>